<commit_message>
feat(slides): source notes on results slides + param chips on circuits slide
- S9/S10: caption 'Số liệu: 10 seeds · mean ± std (ddof=1) · Nguồn: Bảng
  4.1/4.2 luận văn' — proactive answer to 'số này từ đâu' question
- S6: param line 'Tham số/tầng: Basic 4L · Strongly 12L · Random 0 (đóng băng)'
- Verified: 0 mismatch vs canonical, 0 stale, placement does not overlap
  callouts or copyright footer
</commit_message>
<xml_diff>
--- a/slides/KLTN_BaoCao_KhoaKTMT_ChinhThuc.pptx
+++ b/slides/KLTN_BaoCao_KhoaKTMT_ChinhThuc.pptx
@@ -15870,6 +15870,40 @@
           </a:prstGeom>
         </p:spPr>
       </p:pic>
+      <p:sp>
+        <p:nvSpPr>
+          <p:cNvPr id="16" name="TextBox 15"/>
+          <p:cNvSpPr txBox="1"/>
+          <p:nvPr/>
+        </p:nvSpPr>
+        <p:spPr>
+          <a:xfrm>
+            <a:off x="713232" y="6236208"/>
+            <a:ext cx="3566160" cy="256032"/>
+          </a:xfrm>
+          <a:prstGeom prst="rect">
+            <a:avLst/>
+          </a:prstGeom>
+          <a:noFill/>
+        </p:spPr>
+        <p:txBody>
+          <a:bodyPr wrap="none">
+            <a:spAutoFit/>
+          </a:bodyPr>
+          <a:lstStyle/>
+          <a:p>
+            <a:r>
+              <a:rPr sz="1050">
+                <a:solidFill>
+                  <a:srgbClr val="6B6B6B"/>
+                </a:solidFill>
+                <a:latin typeface="Arial"/>
+              </a:rPr>
+              <a:t>Số liệu: 10 seeds · mean ± std (ddof=1) · Nguồn: Bảng 4.2 luận văn</a:t>
+            </a:r>
+          </a:p>
+        </p:txBody>
+      </p:sp>
     </p:spTree>
   </p:cSld>
   <p:clrMapOvr>
@@ -20697,6 +20731,22 @@
               <a:latin typeface="Arial" panose="020B0604020202020204"/>
             </a:endParaRPr>
           </a:p>
+          <a:p>
+            <a:pPr>
+              <a:spcBef>
+                <a:spcPts val="800"/>
+              </a:spcBef>
+            </a:pPr>
+            <a:r>
+              <a:rPr sz="1300" b="1">
+                <a:solidFill>
+                  <a:srgbClr val="1F4E79"/>
+                </a:solidFill>
+                <a:latin typeface="Arial"/>
+              </a:rPr>
+              <a:t>Tham số/tầng: Basic 4L · Strongly 12L · Random 0 (đóng băng)</a:t>
+            </a:r>
+          </a:p>
         </p:txBody>
       </p:sp>
     </p:spTree>
@@ -22141,6 +22191,40 @@
           </a:p>
         </p:txBody>
       </p:sp>
+      <p:sp>
+        <p:nvSpPr>
+          <p:cNvPr id="15" name="TextBox 14"/>
+          <p:cNvSpPr txBox="1"/>
+          <p:nvPr/>
+        </p:nvSpPr>
+        <p:spPr>
+          <a:xfrm>
+            <a:off x="713232" y="6144768"/>
+            <a:ext cx="3566160" cy="256032"/>
+          </a:xfrm>
+          <a:prstGeom prst="rect">
+            <a:avLst/>
+          </a:prstGeom>
+          <a:noFill/>
+        </p:spPr>
+        <p:txBody>
+          <a:bodyPr wrap="none">
+            <a:spAutoFit/>
+          </a:bodyPr>
+          <a:lstStyle/>
+          <a:p>
+            <a:r>
+              <a:rPr sz="1050">
+                <a:solidFill>
+                  <a:srgbClr val="6B6B6B"/>
+                </a:solidFill>
+                <a:latin typeface="Arial"/>
+              </a:rPr>
+              <a:t>Số liệu: 10 seeds · mean ± std (ddof=1) · Nguồn: Bảng 4.1 luận văn</a:t>
+            </a:r>
+          </a:p>
+        </p:txBody>
+      </p:sp>
     </p:spTree>
   </p:cSld>
   <p:clrMapOvr>

</xml_diff>

<commit_message>
fix(slide7): streamline top pipeline diagram and preserve aspect ratio without stretching
</commit_message>
<xml_diff>
--- a/slides/KLTN_BaoCao_KhoaKTMT_ChinhThuc.pptx
+++ b/slides/KLTN_BaoCao_KhoaKTMT_ChinhThuc.pptx
@@ -20,8 +20,8 @@
     <p:sldId id="265" r:id="rId12"/>
     <p:sldId id="266" r:id="rId13"/>
     <p:sldId id="267" r:id="rId14"/>
-    <p:sldId id="268" r:id="rId15"/>
-    <p:sldId id="269" r:id="rId16"/>
+    <p:sldId id="269" r:id="rId15"/>
+    <p:sldId id="268" r:id="rId16"/>
     <p:sldId id="270" r:id="rId17"/>
   </p:sldIdLst>
   <p:sldSz cx="12192000" cy="6858000"/>
@@ -14513,7 +14513,11 @@
             </a:r>
             <a:r>
               <a:rPr sz="3500"/>
-              <a:t> OCTMNIST:</a:t>
+              <a:t> OCTMNIST</a:t>
+            </a:r>
+            <a:r>
+              <a:rPr lang="en-US" sz="3500"/>
+              <a:t>*</a:t>
             </a:r>
             <a:endParaRPr sz="3500"/>
           </a:p>
@@ -14574,7 +14578,7 @@
         </p:nvGraphicFramePr>
         <p:xfrm>
           <a:off x="694944" y="2011680"/>
-          <a:ext cx="5943600" cy="2590800"/>
+          <a:ext cx="5943600" cy="2613660"/>
         </p:xfrm>
         <a:graphic>
           <a:graphicData uri="http://schemas.openxmlformats.org/drawingml/2006/table">
@@ -15449,51 +15453,6 @@
       </p:graphicFrame>
       <p:sp>
         <p:nvSpPr>
-          <p:cNvPr id="7" name="Rounded Rectangle 6"/>
-          <p:cNvSpPr/>
-          <p:nvPr/>
-        </p:nvSpPr>
-        <p:spPr>
-          <a:xfrm>
-            <a:off x="694690" y="4912360"/>
-            <a:ext cx="1874520" cy="1291590"/>
-          </a:xfrm>
-          <a:prstGeom prst="roundRect">
-            <a:avLst/>
-          </a:prstGeom>
-          <a:solidFill>
-            <a:srgbClr val="F8FAFD"/>
-          </a:solidFill>
-          <a:ln w="13970">
-            <a:solidFill>
-              <a:srgbClr val="CDDAE8"/>
-            </a:solidFill>
-          </a:ln>
-        </p:spPr>
-        <p:style>
-          <a:lnRef idx="1">
-            <a:schemeClr val="accent1"/>
-          </a:lnRef>
-          <a:fillRef idx="3">
-            <a:schemeClr val="accent1"/>
-          </a:fillRef>
-          <a:effectRef idx="2">
-            <a:schemeClr val="accent1"/>
-          </a:effectRef>
-          <a:fontRef idx="minor">
-            <a:schemeClr val="lt1"/>
-          </a:fontRef>
-        </p:style>
-        <p:txBody>
-          <a:bodyPr rtlCol="0" anchor="ctr"/>
-          <a:lstStyle/>
-          <a:p>
-            <a:pPr algn="ctr"/>
-          </a:p>
-        </p:txBody>
-      </p:sp>
-      <p:sp>
-        <p:nvSpPr>
           <p:cNvPr id="8" name="TextBox 7"/>
           <p:cNvSpPr txBox="1"/>
           <p:nvPr/>
@@ -15562,51 +15521,6 @@
       </p:sp>
       <p:sp>
         <p:nvSpPr>
-          <p:cNvPr id="9" name="Rounded Rectangle 8"/>
-          <p:cNvSpPr/>
-          <p:nvPr/>
-        </p:nvSpPr>
-        <p:spPr>
-          <a:xfrm>
-            <a:off x="2724785" y="4912360"/>
-            <a:ext cx="1874520" cy="1292860"/>
-          </a:xfrm>
-          <a:prstGeom prst="roundRect">
-            <a:avLst/>
-          </a:prstGeom>
-          <a:solidFill>
-            <a:srgbClr val="F8FAFD"/>
-          </a:solidFill>
-          <a:ln w="13970">
-            <a:solidFill>
-              <a:srgbClr val="CDDAE8"/>
-            </a:solidFill>
-          </a:ln>
-        </p:spPr>
-        <p:style>
-          <a:lnRef idx="1">
-            <a:schemeClr val="accent1"/>
-          </a:lnRef>
-          <a:fillRef idx="3">
-            <a:schemeClr val="accent1"/>
-          </a:fillRef>
-          <a:effectRef idx="2">
-            <a:schemeClr val="accent1"/>
-          </a:effectRef>
-          <a:fontRef idx="minor">
-            <a:schemeClr val="lt1"/>
-          </a:fontRef>
-        </p:style>
-        <p:txBody>
-          <a:bodyPr rtlCol="0" anchor="ctr"/>
-          <a:lstStyle/>
-          <a:p>
-            <a:pPr algn="ctr"/>
-          </a:p>
-        </p:txBody>
-      </p:sp>
-      <p:sp>
-        <p:nvSpPr>
           <p:cNvPr id="10" name="TextBox 9"/>
           <p:cNvSpPr txBox="1"/>
           <p:nvPr/>
@@ -15670,51 +15584,6 @@
             <a:r>
               <a:t>Học góc giúp cải thiện mạch</a:t>
             </a:r>
-          </a:p>
-        </p:txBody>
-      </p:sp>
-      <p:sp>
-        <p:nvSpPr>
-          <p:cNvPr id="11" name="Rounded Rectangle 10"/>
-          <p:cNvSpPr/>
-          <p:nvPr/>
-        </p:nvSpPr>
-        <p:spPr>
-          <a:xfrm>
-            <a:off x="4754880" y="4912360"/>
-            <a:ext cx="1874520" cy="1289685"/>
-          </a:xfrm>
-          <a:prstGeom prst="roundRect">
-            <a:avLst/>
-          </a:prstGeom>
-          <a:solidFill>
-            <a:srgbClr val="F8FAFD"/>
-          </a:solidFill>
-          <a:ln w="13970">
-            <a:solidFill>
-              <a:srgbClr val="CDDAE8"/>
-            </a:solidFill>
-          </a:ln>
-        </p:spPr>
-        <p:style>
-          <a:lnRef idx="1">
-            <a:schemeClr val="accent1"/>
-          </a:lnRef>
-          <a:fillRef idx="3">
-            <a:schemeClr val="accent1"/>
-          </a:fillRef>
-          <a:effectRef idx="2">
-            <a:schemeClr val="accent1"/>
-          </a:effectRef>
-          <a:fontRef idx="minor">
-            <a:schemeClr val="lt1"/>
-          </a:fontRef>
-        </p:style>
-        <p:txBody>
-          <a:bodyPr rtlCol="0" anchor="ctr"/>
-          <a:lstStyle/>
-          <a:p>
-            <a:pPr algn="ctr"/>
           </a:p>
         </p:txBody>
       </p:sp>
@@ -15878,8 +15747,8 @@
         </p:nvSpPr>
         <p:spPr>
           <a:xfrm>
-            <a:off x="713232" y="6236208"/>
-            <a:ext cx="3566160" cy="256032"/>
+            <a:off x="713232" y="6144768"/>
+            <a:ext cx="4307840" cy="252730"/>
           </a:xfrm>
           <a:prstGeom prst="rect">
             <a:avLst/>
@@ -15893,14 +15762,29 @@
           <a:lstStyle/>
           <a:p>
             <a:r>
+              <a:rPr lang="en-US" sz="1050">
+                <a:solidFill>
+                  <a:srgbClr val="6B6B6B"/>
+                </a:solidFill>
+                <a:latin typeface="Arial" panose="020B0604020202020204"/>
+              </a:rPr>
+              <a:t>*: </a:t>
+            </a:r>
+            <a:r>
               <a:rPr sz="1050">
                 <a:solidFill>
                   <a:srgbClr val="6B6B6B"/>
                 </a:solidFill>
-                <a:latin typeface="Arial"/>
+                <a:latin typeface="Arial" panose="020B0604020202020204"/>
               </a:rPr>
               <a:t>Số liệu: 10 seeds · mean ± std (ddof=1) · Nguồn: Bảng 4.2 luận văn</a:t>
             </a:r>
+            <a:endParaRPr sz="1050">
+              <a:solidFill>
+                <a:srgbClr val="6B6B6B"/>
+              </a:solidFill>
+              <a:latin typeface="Arial" panose="020B0604020202020204"/>
+            </a:endParaRPr>
           </a:p>
         </p:txBody>
       </p:sp>
@@ -16195,7 +16079,7 @@
         <p:spPr>
           <a:xfrm>
             <a:off x="841248" y="2185416"/>
-            <a:ext cx="5010912" cy="3036570"/>
+            <a:ext cx="5010912" cy="2805430"/>
           </a:xfrm>
           <a:prstGeom prst="rect">
             <a:avLst/>
@@ -16230,13 +16114,22 @@
               </a:spcAft>
             </a:pPr>
             <a:r>
+              <a:rPr lang="en-US" sz="1500" b="1">
+                <a:solidFill>
+                  <a:srgbClr val="1E1E1E"/>
+                </a:solidFill>
+                <a:latin typeface="Arial" panose="020B0604020202020204"/>
+              </a:rPr>
+              <a:t>- Lượng tử không vượt trội:</a:t>
+            </a:r>
+            <a:r>
               <a:rPr sz="1500" b="1">
                 <a:solidFill>
                   <a:srgbClr val="1E1E1E"/>
                 </a:solidFill>
                 <a:latin typeface="Arial" panose="020B0604020202020204"/>
               </a:rPr>
-              <a:t>1. Không có 'Lượng tử luôn tốt hơn': </a:t>
+              <a:t> </a:t>
             </a:r>
             <a:r>
               <a:rPr sz="1500">
@@ -16264,13 +16157,22 @@
               </a:spcAft>
             </a:pPr>
             <a:r>
+              <a:rPr lang="en-US" sz="1500" b="1">
+                <a:solidFill>
+                  <a:srgbClr val="1E1E1E"/>
+                </a:solidFill>
+                <a:latin typeface="Arial" panose="020B0604020202020204"/>
+              </a:rPr>
+              <a:t>- </a:t>
+            </a:r>
+            <a:r>
               <a:rPr sz="1500" b="1">
                 <a:solidFill>
                   <a:srgbClr val="1E1E1E"/>
                 </a:solidFill>
                 <a:latin typeface="Arial" panose="020B0604020202020204"/>
               </a:rPr>
-              <a:t>2. Mạch cố định (0 cần học) cực kỳ hữu dụng: </a:t>
+              <a:t>Mạch cố định (0 cần học) cực kỳ hữu dụng: </a:t>
             </a:r>
             <a:r>
               <a:rPr sz="1500">
@@ -16298,13 +16200,22 @@
               </a:spcAft>
             </a:pPr>
             <a:r>
+              <a:rPr lang="en-US" sz="1500" b="1">
+                <a:solidFill>
+                  <a:srgbClr val="1E1E1E"/>
+                </a:solidFill>
+                <a:latin typeface="Arial" panose="020B0604020202020204"/>
+              </a:rPr>
+              <a:t>- M</a:t>
+            </a:r>
+            <a:r>
               <a:rPr sz="1500" b="1">
                 <a:solidFill>
                   <a:srgbClr val="1E1E1E"/>
                 </a:solidFill>
                 <a:latin typeface="Arial" panose="020B0604020202020204"/>
               </a:rPr>
-              <a:t>3. Cho mạch tự học có giới hạn: </a:t>
+              <a:t>ạch tự học có giới hạn: </a:t>
             </a:r>
             <a:r>
               <a:rPr sz="1500">
@@ -16413,13 +16324,22 @@
               </a:spcAft>
             </a:pPr>
             <a:r>
+              <a:rPr lang="en-US" sz="1500" b="1">
+                <a:solidFill>
+                  <a:srgbClr val="1E1E1E"/>
+                </a:solidFill>
+                <a:latin typeface="Arial" panose="020B0604020202020204"/>
+              </a:rPr>
+              <a:t>- </a:t>
+            </a:r>
+            <a:r>
               <a:rPr sz="1500" b="1">
                 <a:solidFill>
                   <a:srgbClr val="1E1E1E"/>
                 </a:solidFill>
                 <a:latin typeface="Arial" panose="020B0604020202020204"/>
               </a:rPr>
-              <a:t>1. Chạy thử trên máy tính lượng tử thật: </a:t>
+              <a:t>Chạy thử trên máy tính lượng tử thật: </a:t>
             </a:r>
             <a:r>
               <a:rPr sz="1500">
@@ -16447,13 +16367,22 @@
               </a:spcAft>
             </a:pPr>
             <a:r>
+              <a:rPr lang="en-US" sz="1500" b="1">
+                <a:solidFill>
+                  <a:srgbClr val="1E1E1E"/>
+                </a:solidFill>
+                <a:latin typeface="Arial" panose="020B0604020202020204"/>
+              </a:rPr>
+              <a:t>- </a:t>
+            </a:r>
+            <a:r>
               <a:rPr sz="1500" b="1">
                 <a:solidFill>
                   <a:srgbClr val="1E1E1E"/>
                 </a:solidFill>
                 <a:latin typeface="Arial" panose="020B0604020202020204"/>
               </a:rPr>
-              <a:t>2. Dùng GPU mở rộng số Qubit: </a:t>
+              <a:t>Dùng GPU mở rộng số Qubit: </a:t>
             </a:r>
             <a:r>
               <a:rPr sz="1500">
@@ -16462,7 +16391,7 @@
                 </a:solidFill>
                 <a:latin typeface="Arial" panose="020B0604020202020204"/>
               </a:rPr>
-              <a:t>Áp dụng công nghệ NVIDIA cuQuantum để mô phỏng mạch 8–16 qubits, giúp giải quyết bài toán lớn 97,000 ảnh OCT.</a:t>
+              <a:t>Áp dụng NVIDIA cuQuantum để mô phỏng mạch 8–16 qubits, giúp giải quyết bài toán lớn 97,000 ảnh OCT.</a:t>
             </a:r>
             <a:endParaRPr sz="1500">
               <a:solidFill>
@@ -16481,13 +16410,22 @@
               </a:spcAft>
             </a:pPr>
             <a:r>
+              <a:rPr lang="en-US" sz="1500" b="1">
+                <a:solidFill>
+                  <a:srgbClr val="1E1E1E"/>
+                </a:solidFill>
+                <a:latin typeface="Arial" panose="020B0604020202020204"/>
+              </a:rPr>
+              <a:t>- </a:t>
+            </a:r>
+            <a:r>
               <a:rPr sz="1500" b="1">
                 <a:solidFill>
                   <a:srgbClr val="1E1E1E"/>
                 </a:solidFill>
                 <a:latin typeface="Arial" panose="020B0604020202020204"/>
               </a:rPr>
-              <a:t>3. Đổi mới cách nén dữ liệu: </a:t>
+              <a:t>Đổi mới cách nén dữ liệu: </a:t>
             </a:r>
             <a:r>
               <a:rPr sz="1500">
@@ -16514,6 +16452,15 @@
                 <a:spcPts val="200"/>
               </a:spcAft>
             </a:pPr>
+            <a:r>
+              <a:rPr lang="en-US" sz="1500" b="1">
+                <a:solidFill>
+                  <a:srgbClr val="1E1E1E"/>
+                </a:solidFill>
+                <a:latin typeface="Arial" panose="020B0604020202020204"/>
+              </a:rPr>
+              <a:t>- </a:t>
+            </a:r>
             <a:r>
               <a:rPr sz="1500" b="1">
                 <a:solidFill>
@@ -16568,7 +16515,52 @@
       </p:grpSpPr>
       <p:sp>
         <p:nvSpPr>
-          <p:cNvPr id="2" name="Title 1"/>
+          <p:cNvPr id="2" name="Footer Placeholder 1"/>
+          <p:cNvSpPr>
+            <a:spLocks noGrp="1"/>
+          </p:cNvSpPr>
+          <p:nvPr>
+            <p:ph type="ftr" sz="quarter" idx="11"/>
+          </p:nvPr>
+        </p:nvSpPr>
+        <p:spPr/>
+        <p:txBody>
+          <a:bodyPr/>
+          <a:lstStyle/>
+          <a:p>
+            <a:r>
+              <a:rPr lang="en-US"/>
+              <a:t>Copyrights 2024 CE-UIT. All Rights Reserved.</a:t>
+            </a:r>
+            <a:endParaRPr lang="en-US" dirty="0"/>
+          </a:p>
+        </p:txBody>
+      </p:sp>
+      <p:sp>
+        <p:nvSpPr>
+          <p:cNvPr id="3" name="Slide Number Placeholder 2"/>
+          <p:cNvSpPr>
+            <a:spLocks noGrp="1"/>
+          </p:cNvSpPr>
+          <p:nvPr>
+            <p:ph type="sldNum" sz="quarter" idx="12"/>
+          </p:nvPr>
+        </p:nvSpPr>
+        <p:spPr/>
+        <p:txBody>
+          <a:bodyPr/>
+          <a:lstStyle/>
+          <a:p>
+            <a:fld id="{48F63A3B-78C7-47BE-AE5E-E10140E04643}" type="slidenum">
+              <a:rPr lang="en-US" smtClean="0"/>
+            </a:fld>
+            <a:endParaRPr lang="en-US" dirty="0"/>
+          </a:p>
+        </p:txBody>
+      </p:sp>
+      <p:sp>
+        <p:nvSpPr>
+          <p:cNvPr id="4" name="Title 3"/>
           <p:cNvSpPr>
             <a:spLocks noGrp="1"/>
           </p:cNvSpPr>
@@ -16582,19 +16574,21 @@
           <a:lstStyle/>
           <a:p>
             <a:r>
-              <a:t>Tài liệu Tham khảo</a:t>
-            </a:r>
-          </a:p>
-        </p:txBody>
-      </p:sp>
-      <p:sp>
-        <p:nvSpPr>
-          <p:cNvPr id="4" name="Footer Placeholder 3"/>
+              <a:rPr lang="en-US" dirty="0"/>
+              <a:t>HỎI VÀ ĐÁP</a:t>
+            </a:r>
+            <a:endParaRPr lang="en-US" dirty="0"/>
+          </a:p>
+        </p:txBody>
+      </p:sp>
+      <p:sp>
+        <p:nvSpPr>
+          <p:cNvPr id="5" name="Text Placeholder 4"/>
           <p:cNvSpPr>
             <a:spLocks noGrp="1"/>
           </p:cNvSpPr>
           <p:nvPr>
-            <p:ph type="ftr" sz="quarter" idx="11"/>
+            <p:ph type="body" idx="1"/>
           </p:nvPr>
         </p:nvSpPr>
         <p:spPr/>
@@ -16602,22 +16596,18 @@
           <a:bodyPr/>
           <a:lstStyle/>
           <a:p>
-            <a:r>
-              <a:rPr lang="en-US"/>
-              <a:t>Copyrights 2024 CE-UIT. All Rights Reserved.</a:t>
-            </a:r>
-            <a:endParaRPr lang="en-US" dirty="0"/>
-          </a:p>
-        </p:txBody>
-      </p:sp>
-      <p:sp>
-        <p:nvSpPr>
-          <p:cNvPr id="5" name="Slide Number Placeholder 4"/>
+            <a:endParaRPr lang="en-US"/>
+          </a:p>
+        </p:txBody>
+      </p:sp>
+      <p:sp>
+        <p:nvSpPr>
+          <p:cNvPr id="6" name="Content Placeholder 5"/>
           <p:cNvSpPr>
             <a:spLocks noGrp="1"/>
           </p:cNvSpPr>
           <p:nvPr>
-            <p:ph type="sldNum" sz="quarter" idx="12"/>
+            <p:ph sz="quarter" idx="13"/>
           </p:nvPr>
         </p:nvSpPr>
         <p:spPr/>
@@ -16625,271 +16615,11 @@
           <a:bodyPr/>
           <a:lstStyle/>
           <a:p>
-            <a:fld id="{48F63A3B-78C7-47BE-AE5E-E10140E04643}" type="slidenum">
-              <a:rPr lang="en-US" smtClean="0"/>
-            </a:fld>
+            <a:r>
+              <a:rPr lang="en-US" dirty="0"/>
+              <a:t>05</a:t>
+            </a:r>
             <a:endParaRPr lang="en-US" dirty="0"/>
-          </a:p>
-        </p:txBody>
-      </p:sp>
-      <p:sp>
-        <p:nvSpPr>
-          <p:cNvPr id="7" name="TextBox 6"/>
-          <p:cNvSpPr txBox="1"/>
-          <p:nvPr/>
-        </p:nvSpPr>
-        <p:spPr>
-          <a:xfrm>
-            <a:off x="841375" y="2225675"/>
-            <a:ext cx="10497185" cy="3492500"/>
-          </a:xfrm>
-          <a:prstGeom prst="rect">
-            <a:avLst/>
-          </a:prstGeom>
-          <a:noFill/>
-        </p:spPr>
-        <p:txBody>
-          <a:bodyPr wrap="square" lIns="0" tIns="0" rIns="0" bIns="0">
-            <a:noAutofit/>
-          </a:bodyPr>
-          <a:lstStyle/>
-          <a:p>
-            <a:pPr algn="just">
-              <a:spcBef>
-                <a:spcPts val="600"/>
-              </a:spcBef>
-              <a:spcAft>
-                <a:spcPts val="200"/>
-              </a:spcAft>
-            </a:pPr>
-            <a:r>
-              <a:rPr sz="1500" b="1">
-                <a:solidFill>
-                  <a:srgbClr val="1E1E1E"/>
-                </a:solidFill>
-                <a:latin typeface="Arial" panose="020B0604020202020204"/>
-              </a:rPr>
-              <a:t>[1] Henderson et al. (2020) </a:t>
-            </a:r>
-            <a:r>
-              <a:rPr sz="1500">
-                <a:solidFill>
-                  <a:srgbClr val="1E1E1E"/>
-                </a:solidFill>
-                <a:latin typeface="Arial" panose="020B0604020202020204"/>
-              </a:rPr>
-              <a:t>Quanvolutional Neural Networks. Quantum Machine Intelligence, 2(1), 2. (Bài báo gốc đề xuất ý tưởng Quanvolution).</a:t>
-            </a:r>
-            <a:endParaRPr sz="1500">
-              <a:solidFill>
-                <a:srgbClr val="1E1E1E"/>
-              </a:solidFill>
-              <a:latin typeface="Arial" panose="020B0604020202020204"/>
-            </a:endParaRPr>
-          </a:p>
-          <a:p>
-            <a:pPr algn="just">
-              <a:spcBef>
-                <a:spcPts val="600"/>
-              </a:spcBef>
-              <a:spcAft>
-                <a:spcPts val="200"/>
-              </a:spcAft>
-            </a:pPr>
-            <a:r>
-              <a:rPr sz="1500" b="1">
-                <a:solidFill>
-                  <a:srgbClr val="1E1E1E"/>
-                </a:solidFill>
-                <a:latin typeface="Arial" panose="020B0604020202020204"/>
-              </a:rPr>
-              <a:t>[2] Cong, Choi, &amp; Lukin (2019) </a:t>
-            </a:r>
-            <a:r>
-              <a:rPr sz="1500">
-                <a:solidFill>
-                  <a:srgbClr val="1E1E1E"/>
-                </a:solidFill>
-                <a:latin typeface="Arial" panose="020B0604020202020204"/>
-              </a:rPr>
-              <a:t>Quantum Convolutional Neural Networks. Nature Physics, 15(12), 1273–1278. (Mạng tích chập lượng tử thuần túy).</a:t>
-            </a:r>
-            <a:endParaRPr sz="1500">
-              <a:solidFill>
-                <a:srgbClr val="1E1E1E"/>
-              </a:solidFill>
-              <a:latin typeface="Arial" panose="020B0604020202020204"/>
-            </a:endParaRPr>
-          </a:p>
-          <a:p>
-            <a:pPr algn="just">
-              <a:spcBef>
-                <a:spcPts val="600"/>
-              </a:spcBef>
-              <a:spcAft>
-                <a:spcPts val="200"/>
-              </a:spcAft>
-            </a:pPr>
-            <a:r>
-              <a:rPr sz="1500" b="1">
-                <a:solidFill>
-                  <a:srgbClr val="1E1E1E"/>
-                </a:solidFill>
-                <a:latin typeface="Arial" panose="020B0604020202020204"/>
-              </a:rPr>
-              <a:t>[3] Schuld &amp; Killoran (2022) </a:t>
-            </a:r>
-            <a:r>
-              <a:rPr sz="1500">
-                <a:solidFill>
-                  <a:srgbClr val="1E1E1E"/>
-                </a:solidFill>
-                <a:latin typeface="Arial" panose="020B0604020202020204"/>
-              </a:rPr>
-              <a:t>Is Quantum Advantage the Right Goal for Quantum Machine Learning? PRX Quantum, 3(3), 030101. (Bàn về vai trò thực tế của máy học lượng tử).</a:t>
-            </a:r>
-            <a:endParaRPr sz="1500">
-              <a:solidFill>
-                <a:srgbClr val="1E1E1E"/>
-              </a:solidFill>
-              <a:latin typeface="Arial" panose="020B0604020202020204"/>
-            </a:endParaRPr>
-          </a:p>
-          <a:p>
-            <a:pPr algn="just">
-              <a:spcBef>
-                <a:spcPts val="600"/>
-              </a:spcBef>
-              <a:spcAft>
-                <a:spcPts val="200"/>
-              </a:spcAft>
-            </a:pPr>
-            <a:r>
-              <a:rPr sz="1500" b="1">
-                <a:solidFill>
-                  <a:srgbClr val="1E1E1E"/>
-                </a:solidFill>
-                <a:latin typeface="Arial" panose="020B0604020202020204"/>
-              </a:rPr>
-              <a:t>[4] Yang et al. (2023) </a:t>
-            </a:r>
-            <a:r>
-              <a:rPr sz="1500">
-                <a:solidFill>
-                  <a:srgbClr val="1E1E1E"/>
-                </a:solidFill>
-                <a:latin typeface="Arial" panose="020B0604020202020204"/>
-              </a:rPr>
-              <a:t>MedMNIST v2: A Large-Scale Lightweight Benchmark for Biomedical Image Classification. Scientific Data (Nature), 10(1), 41.</a:t>
-            </a:r>
-            <a:endParaRPr sz="1500">
-              <a:solidFill>
-                <a:srgbClr val="1E1E1E"/>
-              </a:solidFill>
-              <a:latin typeface="Arial" panose="020B0604020202020204"/>
-            </a:endParaRPr>
-          </a:p>
-          <a:p>
-            <a:pPr algn="just">
-              <a:spcBef>
-                <a:spcPts val="600"/>
-              </a:spcBef>
-              <a:spcAft>
-                <a:spcPts val="200"/>
-              </a:spcAft>
-            </a:pPr>
-            <a:r>
-              <a:rPr sz="1500" b="1">
-                <a:solidFill>
-                  <a:srgbClr val="1E1E1E"/>
-                </a:solidFill>
-                <a:latin typeface="Arial" panose="020B0604020202020204"/>
-              </a:rPr>
-              <a:t>[5] McClean et al. (2018) </a:t>
-            </a:r>
-            <a:r>
-              <a:rPr sz="1500">
-                <a:solidFill>
-                  <a:srgbClr val="1E1E1E"/>
-                </a:solidFill>
-                <a:latin typeface="Arial" panose="020B0604020202020204"/>
-              </a:rPr>
-              <a:t>Barren Plateaus in Quantum Neural Network Training Landscapes. Nature Communications, 9(1), 4812.</a:t>
-            </a:r>
-            <a:endParaRPr sz="1500">
-              <a:solidFill>
-                <a:srgbClr val="1E1E1E"/>
-              </a:solidFill>
-              <a:latin typeface="Arial" panose="020B0604020202020204"/>
-            </a:endParaRPr>
-          </a:p>
-          <a:p>
-            <a:pPr algn="just">
-              <a:spcBef>
-                <a:spcPts val="600"/>
-              </a:spcBef>
-              <a:spcAft>
-                <a:spcPts val="200"/>
-              </a:spcAft>
-            </a:pPr>
-            <a:r>
-              <a:rPr sz="1500" b="1">
-                <a:solidFill>
-                  <a:srgbClr val="1E1E1E"/>
-                </a:solidFill>
-                <a:latin typeface="Arial" panose="020B0604020202020204"/>
-              </a:rPr>
-              <a:t>[6] Matondo-Mvula &amp; Elleithy (2024) </a:t>
-            </a:r>
-            <a:r>
-              <a:rPr sz="1500">
-                <a:solidFill>
-                  <a:srgbClr val="1E1E1E"/>
-                </a:solidFill>
-                <a:latin typeface="Arial" panose="020B0604020202020204"/>
-              </a:rPr>
-              <a:t>Breast Cancer Detection with Quanvolutional Neural Networks. Entropy, 26(8), 630.</a:t>
-            </a:r>
-            <a:endParaRPr sz="1500">
-              <a:solidFill>
-                <a:srgbClr val="1E1E1E"/>
-              </a:solidFill>
-              <a:latin typeface="Arial" panose="020B0604020202020204"/>
-            </a:endParaRPr>
-          </a:p>
-          <a:p>
-            <a:pPr algn="just">
-              <a:spcBef>
-                <a:spcPts val="600"/>
-              </a:spcBef>
-              <a:spcAft>
-                <a:spcPts val="200"/>
-              </a:spcAft>
-            </a:pPr>
-            <a:r>
-              <a:rPr sz="1500" b="1">
-                <a:solidFill>
-                  <a:srgbClr val="1E1E1E"/>
-                </a:solidFill>
-                <a:latin typeface="Arial" panose="020B0604020202020204"/>
-              </a:rPr>
-              <a:t>Toàn bộ tài liệu đối chiếu: </a:t>
-            </a:r>
-            <a:r>
-              <a:rPr sz="1500">
-                <a:solidFill>
-                  <a:srgbClr val="1E1E1E"/>
-                </a:solidFill>
-                <a:latin typeface="Arial" panose="020B0604020202020204"/>
-              </a:rPr>
-              <a:t>19 công trình quốc tế được trích dẫn và phân tích chi tiết trong cuốn Luận văn và Bài báo.</a:t>
-            </a:r>
-            <a:endParaRPr sz="1500">
-              <a:solidFill>
-                <a:srgbClr val="1E1E1E"/>
-              </a:solidFill>
-              <a:latin typeface="Arial" panose="020B0604020202020204"/>
-            </a:endParaRPr>
           </a:p>
         </p:txBody>
       </p:sp>
@@ -16920,7 +16650,28 @@
       </p:grpSpPr>
       <p:sp>
         <p:nvSpPr>
-          <p:cNvPr id="2" name="Footer Placeholder 1"/>
+          <p:cNvPr id="2" name="Title 1"/>
+          <p:cNvSpPr>
+            <a:spLocks noGrp="1"/>
+          </p:cNvSpPr>
+          <p:nvPr>
+            <p:ph type="title"/>
+          </p:nvPr>
+        </p:nvSpPr>
+        <p:spPr/>
+        <p:txBody>
+          <a:bodyPr/>
+          <a:lstStyle/>
+          <a:p>
+            <a:r>
+              <a:t>Tài liệu Tham khảo</a:t>
+            </a:r>
+          </a:p>
+        </p:txBody>
+      </p:sp>
+      <p:sp>
+        <p:nvSpPr>
+          <p:cNvPr id="4" name="Footer Placeholder 3"/>
           <p:cNvSpPr>
             <a:spLocks noGrp="1"/>
           </p:cNvSpPr>
@@ -16943,7 +16694,7 @@
       </p:sp>
       <p:sp>
         <p:nvSpPr>
-          <p:cNvPr id="3" name="Slide Number Placeholder 2"/>
+          <p:cNvPr id="5" name="Slide Number Placeholder 4"/>
           <p:cNvSpPr>
             <a:spLocks noGrp="1"/>
           </p:cNvSpPr>
@@ -16965,66 +16716,262 @@
       </p:sp>
       <p:sp>
         <p:nvSpPr>
-          <p:cNvPr id="4" name="Title 3"/>
-          <p:cNvSpPr>
-            <a:spLocks noGrp="1"/>
-          </p:cNvSpPr>
-          <p:nvPr>
-            <p:ph type="title"/>
-          </p:nvPr>
-        </p:nvSpPr>
-        <p:spPr/>
-        <p:txBody>
-          <a:bodyPr/>
+          <p:cNvPr id="7" name="TextBox 6"/>
+          <p:cNvSpPr txBox="1"/>
+          <p:nvPr/>
+        </p:nvSpPr>
+        <p:spPr>
+          <a:xfrm>
+            <a:off x="841375" y="2225675"/>
+            <a:ext cx="10497185" cy="3492500"/>
+          </a:xfrm>
+          <a:prstGeom prst="rect">
+            <a:avLst/>
+          </a:prstGeom>
+          <a:noFill/>
+        </p:spPr>
+        <p:txBody>
+          <a:bodyPr wrap="square" lIns="0" tIns="0" rIns="0" bIns="0">
+            <a:noAutofit/>
+          </a:bodyPr>
           <a:lstStyle/>
           <a:p>
-            <a:r>
-              <a:rPr lang="en-US" dirty="0"/>
-              <a:t>HỎI VÀ ĐÁP</a:t>
-            </a:r>
-            <a:endParaRPr lang="en-US" dirty="0"/>
-          </a:p>
-        </p:txBody>
-      </p:sp>
-      <p:sp>
-        <p:nvSpPr>
-          <p:cNvPr id="5" name="Text Placeholder 4"/>
-          <p:cNvSpPr>
-            <a:spLocks noGrp="1"/>
-          </p:cNvSpPr>
-          <p:nvPr>
-            <p:ph type="body" idx="1"/>
-          </p:nvPr>
-        </p:nvSpPr>
-        <p:spPr/>
-        <p:txBody>
-          <a:bodyPr/>
-          <a:lstStyle/>
-          <a:p>
-            <a:endParaRPr lang="en-US"/>
-          </a:p>
-        </p:txBody>
-      </p:sp>
-      <p:sp>
-        <p:nvSpPr>
-          <p:cNvPr id="6" name="Content Placeholder 5"/>
-          <p:cNvSpPr>
-            <a:spLocks noGrp="1"/>
-          </p:cNvSpPr>
-          <p:nvPr>
-            <p:ph sz="quarter" idx="13"/>
-          </p:nvPr>
-        </p:nvSpPr>
-        <p:spPr/>
-        <p:txBody>
-          <a:bodyPr/>
-          <a:lstStyle/>
-          <a:p>
-            <a:r>
-              <a:rPr lang="en-US" dirty="0"/>
-              <a:t>05</a:t>
-            </a:r>
-            <a:endParaRPr lang="en-US" dirty="0"/>
+            <a:pPr algn="just">
+              <a:spcBef>
+                <a:spcPts val="600"/>
+              </a:spcBef>
+              <a:spcAft>
+                <a:spcPts val="200"/>
+              </a:spcAft>
+            </a:pPr>
+            <a:r>
+              <a:rPr sz="1500" b="1">
+                <a:solidFill>
+                  <a:srgbClr val="1E1E1E"/>
+                </a:solidFill>
+                <a:latin typeface="Arial" panose="020B0604020202020204"/>
+              </a:rPr>
+              <a:t>[1] Henderson et al. (2020) </a:t>
+            </a:r>
+            <a:r>
+              <a:rPr sz="1500">
+                <a:solidFill>
+                  <a:srgbClr val="1E1E1E"/>
+                </a:solidFill>
+                <a:latin typeface="Arial" panose="020B0604020202020204"/>
+              </a:rPr>
+              <a:t>Quanvolutional Neural Networks. Quantum Machine Intelligence, 2(1), 2. (Bài báo gốc đề xuất ý tưởng Quanvolution).</a:t>
+            </a:r>
+            <a:endParaRPr sz="1500">
+              <a:solidFill>
+                <a:srgbClr val="1E1E1E"/>
+              </a:solidFill>
+              <a:latin typeface="Arial" panose="020B0604020202020204"/>
+            </a:endParaRPr>
+          </a:p>
+          <a:p>
+            <a:pPr algn="just">
+              <a:spcBef>
+                <a:spcPts val="600"/>
+              </a:spcBef>
+              <a:spcAft>
+                <a:spcPts val="200"/>
+              </a:spcAft>
+            </a:pPr>
+            <a:r>
+              <a:rPr sz="1500" b="1">
+                <a:solidFill>
+                  <a:srgbClr val="1E1E1E"/>
+                </a:solidFill>
+                <a:latin typeface="Arial" panose="020B0604020202020204"/>
+              </a:rPr>
+              <a:t>[2] Cong, Choi, &amp; Lukin (2019) </a:t>
+            </a:r>
+            <a:r>
+              <a:rPr sz="1500">
+                <a:solidFill>
+                  <a:srgbClr val="1E1E1E"/>
+                </a:solidFill>
+                <a:latin typeface="Arial" panose="020B0604020202020204"/>
+              </a:rPr>
+              <a:t>Quantum Convolutional Neural Networks. Nature Physics, 15(12), 1273–1278. (Mạng tích chập lượng tử thuần túy).</a:t>
+            </a:r>
+            <a:endParaRPr sz="1500">
+              <a:solidFill>
+                <a:srgbClr val="1E1E1E"/>
+              </a:solidFill>
+              <a:latin typeface="Arial" panose="020B0604020202020204"/>
+            </a:endParaRPr>
+          </a:p>
+          <a:p>
+            <a:pPr algn="just">
+              <a:spcBef>
+                <a:spcPts val="600"/>
+              </a:spcBef>
+              <a:spcAft>
+                <a:spcPts val="200"/>
+              </a:spcAft>
+            </a:pPr>
+            <a:r>
+              <a:rPr sz="1500" b="1">
+                <a:solidFill>
+                  <a:srgbClr val="1E1E1E"/>
+                </a:solidFill>
+                <a:latin typeface="Arial" panose="020B0604020202020204"/>
+              </a:rPr>
+              <a:t>[3] Schuld &amp; Killoran (2022) </a:t>
+            </a:r>
+            <a:r>
+              <a:rPr sz="1500">
+                <a:solidFill>
+                  <a:srgbClr val="1E1E1E"/>
+                </a:solidFill>
+                <a:latin typeface="Arial" panose="020B0604020202020204"/>
+              </a:rPr>
+              <a:t>Is Quantum Advantage the Right Goal for Quantum Machine Learning? PRX Quantum, 3(3), 030101. (Bàn về vai trò thực tế của máy học lượng tử).</a:t>
+            </a:r>
+            <a:endParaRPr sz="1500">
+              <a:solidFill>
+                <a:srgbClr val="1E1E1E"/>
+              </a:solidFill>
+              <a:latin typeface="Arial" panose="020B0604020202020204"/>
+            </a:endParaRPr>
+          </a:p>
+          <a:p>
+            <a:pPr algn="just">
+              <a:spcBef>
+                <a:spcPts val="600"/>
+              </a:spcBef>
+              <a:spcAft>
+                <a:spcPts val="200"/>
+              </a:spcAft>
+            </a:pPr>
+            <a:r>
+              <a:rPr sz="1500" b="1">
+                <a:solidFill>
+                  <a:srgbClr val="1E1E1E"/>
+                </a:solidFill>
+                <a:latin typeface="Arial" panose="020B0604020202020204"/>
+              </a:rPr>
+              <a:t>[4] Yang et al. (2023) </a:t>
+            </a:r>
+            <a:r>
+              <a:rPr sz="1500">
+                <a:solidFill>
+                  <a:srgbClr val="1E1E1E"/>
+                </a:solidFill>
+                <a:latin typeface="Arial" panose="020B0604020202020204"/>
+              </a:rPr>
+              <a:t>MedMNIST v2: A Large-Scale Lightweight Benchmark for Biomedical Image Classification. Scientific Data (Nature), 10(1), 41.</a:t>
+            </a:r>
+            <a:endParaRPr sz="1500">
+              <a:solidFill>
+                <a:srgbClr val="1E1E1E"/>
+              </a:solidFill>
+              <a:latin typeface="Arial" panose="020B0604020202020204"/>
+            </a:endParaRPr>
+          </a:p>
+          <a:p>
+            <a:pPr algn="just">
+              <a:spcBef>
+                <a:spcPts val="600"/>
+              </a:spcBef>
+              <a:spcAft>
+                <a:spcPts val="200"/>
+              </a:spcAft>
+            </a:pPr>
+            <a:r>
+              <a:rPr sz="1500" b="1">
+                <a:solidFill>
+                  <a:srgbClr val="1E1E1E"/>
+                </a:solidFill>
+                <a:latin typeface="Arial" panose="020B0604020202020204"/>
+              </a:rPr>
+              <a:t>[5] McClean et al. (2018) </a:t>
+            </a:r>
+            <a:r>
+              <a:rPr sz="1500">
+                <a:solidFill>
+                  <a:srgbClr val="1E1E1E"/>
+                </a:solidFill>
+                <a:latin typeface="Arial" panose="020B0604020202020204"/>
+              </a:rPr>
+              <a:t>Barren Plateaus in Quantum Neural Network Training Landscapes. Nature Communications, 9(1), 4812.</a:t>
+            </a:r>
+            <a:endParaRPr sz="1500">
+              <a:solidFill>
+                <a:srgbClr val="1E1E1E"/>
+              </a:solidFill>
+              <a:latin typeface="Arial" panose="020B0604020202020204"/>
+            </a:endParaRPr>
+          </a:p>
+          <a:p>
+            <a:pPr algn="just">
+              <a:spcBef>
+                <a:spcPts val="600"/>
+              </a:spcBef>
+              <a:spcAft>
+                <a:spcPts val="200"/>
+              </a:spcAft>
+            </a:pPr>
+            <a:r>
+              <a:rPr sz="1500" b="1">
+                <a:solidFill>
+                  <a:srgbClr val="1E1E1E"/>
+                </a:solidFill>
+                <a:latin typeface="Arial" panose="020B0604020202020204"/>
+              </a:rPr>
+              <a:t>[6] Matondo-Mvula &amp; Elleithy (2024) </a:t>
+            </a:r>
+            <a:r>
+              <a:rPr sz="1500">
+                <a:solidFill>
+                  <a:srgbClr val="1E1E1E"/>
+                </a:solidFill>
+                <a:latin typeface="Arial" panose="020B0604020202020204"/>
+              </a:rPr>
+              <a:t>Breast Cancer Detection with Quanvolutional Neural Networks. Entropy, 26(8), 630.</a:t>
+            </a:r>
+            <a:endParaRPr sz="1500">
+              <a:solidFill>
+                <a:srgbClr val="1E1E1E"/>
+              </a:solidFill>
+              <a:latin typeface="Arial" panose="020B0604020202020204"/>
+            </a:endParaRPr>
+          </a:p>
+          <a:p>
+            <a:pPr algn="just">
+              <a:spcBef>
+                <a:spcPts val="600"/>
+              </a:spcBef>
+              <a:spcAft>
+                <a:spcPts val="200"/>
+              </a:spcAft>
+            </a:pPr>
+            <a:r>
+              <a:rPr sz="1500" b="1">
+                <a:solidFill>
+                  <a:srgbClr val="1E1E1E"/>
+                </a:solidFill>
+                <a:latin typeface="Arial" panose="020B0604020202020204"/>
+              </a:rPr>
+              <a:t>Toàn bộ tài liệu đối chiếu: </a:t>
+            </a:r>
+            <a:r>
+              <a:rPr sz="1500">
+                <a:solidFill>
+                  <a:srgbClr val="1E1E1E"/>
+                </a:solidFill>
+                <a:latin typeface="Arial" panose="020B0604020202020204"/>
+              </a:rPr>
+              <a:t>19 công trình quốc tế được trích dẫn và phân tích chi tiết trong cuốn Luận văn và Bài báo.</a:t>
+            </a:r>
+            <a:endParaRPr sz="1500">
+              <a:solidFill>
+                <a:srgbClr val="1E1E1E"/>
+              </a:solidFill>
+              <a:latin typeface="Arial" panose="020B0604020202020204"/>
+            </a:endParaRPr>
           </a:p>
         </p:txBody>
       </p:sp>
@@ -18253,7 +18200,7 @@
             </a:endParaRPr>
           </a:p>
           <a:p>
-            <a:pPr algn="just">
+            <a:pPr algn="l">
               <a:spcBef>
                 <a:spcPts val="600"/>
               </a:spcBef>
@@ -18289,7 +18236,7 @@
             </a:endParaRPr>
           </a:p>
           <a:p>
-            <a:pPr algn="just">
+            <a:pPr algn="l">
               <a:spcBef>
                 <a:spcPts val="600"/>
               </a:spcBef>
@@ -18305,7 +18252,27 @@
                 <a:latin typeface="Arial" panose="020B0604020202020204"/>
                 <a:sym typeface="+mn-ea"/>
               </a:rPr>
-              <a:t>• Bản Demo trực tiếp (Jupyter Notebook): </a:t>
+              <a:t>•</a:t>
+            </a:r>
+            <a:r>
+              <a:rPr lang="en-US" sz="1200" b="1">
+                <a:solidFill>
+                  <a:srgbClr val="1E1E1E"/>
+                </a:solidFill>
+                <a:latin typeface="Arial" panose="020B0604020202020204"/>
+                <a:sym typeface="+mn-ea"/>
+              </a:rPr>
+              <a:t> </a:t>
+            </a:r>
+            <a:r>
+              <a:rPr sz="1200" b="1">
+                <a:solidFill>
+                  <a:srgbClr val="1E1E1E"/>
+                </a:solidFill>
+                <a:latin typeface="Arial" panose="020B0604020202020204"/>
+                <a:sym typeface="+mn-ea"/>
+              </a:rPr>
+              <a:t>Demo trực tiếp (Jupyter Notebook): </a:t>
             </a:r>
             <a:r>
               <a:rPr sz="1200">
@@ -18325,7 +18292,7 @@
             </a:endParaRPr>
           </a:p>
           <a:p>
-            <a:pPr algn="just">
+            <a:pPr algn="l">
               <a:spcBef>
                 <a:spcPts val="600"/>
               </a:spcBef>
@@ -18341,7 +18308,7 @@
                 <a:latin typeface="Arial" panose="020B0604020202020204"/>
                 <a:sym typeface="+mn-ea"/>
               </a:rPr>
-              <a:t>• Video demo dự phòng: </a:t>
+              <a:t>• Video demo: </a:t>
             </a:r>
             <a:r>
               <a:rPr sz="1200">
@@ -18361,7 +18328,7 @@
             </a:endParaRPr>
           </a:p>
           <a:p>
-            <a:pPr algn="just">
+            <a:pPr algn="l">
               <a:spcBef>
                 <a:spcPts val="600"/>
               </a:spcBef>
@@ -18377,7 +18344,27 @@
                 <a:latin typeface="Arial" panose="020B0604020202020204"/>
                 <a:sym typeface="+mn-ea"/>
               </a:rPr>
-              <a:t>• Cam kết liêm chính học thuật: </a:t>
+              <a:t>• Cam kết</a:t>
+            </a:r>
+            <a:r>
+              <a:rPr lang="en-US" sz="1200" b="1">
+                <a:solidFill>
+                  <a:srgbClr val="1E1E1E"/>
+                </a:solidFill>
+                <a:latin typeface="Arial" panose="020B0604020202020204"/>
+                <a:sym typeface="+mn-ea"/>
+              </a:rPr>
+              <a:t>:</a:t>
+            </a:r>
+            <a:r>
+              <a:rPr sz="1200" b="1">
+                <a:solidFill>
+                  <a:srgbClr val="1E1E1E"/>
+                </a:solidFill>
+                <a:latin typeface="Arial" panose="020B0604020202020204"/>
+                <a:sym typeface="+mn-ea"/>
+              </a:rPr>
+              <a:t> </a:t>
             </a:r>
             <a:r>
               <a:rPr sz="1200">
@@ -19474,8 +19461,8 @@
         </p:nvSpPr>
         <p:spPr>
           <a:xfrm>
-            <a:off x="768096" y="2176272"/>
-            <a:ext cx="1865376" cy="786384"/>
+            <a:off x="767461" y="2292477"/>
+            <a:ext cx="1865376" cy="299085"/>
           </a:xfrm>
           <a:prstGeom prst="rect">
             <a:avLst/>
@@ -19498,22 +19485,6 @@
             </a:pPr>
             <a:r>
               <a:t>THỰC TRẠNG</a:t>
-            </a:r>
-          </a:p>
-          <a:p>
-            <a:pPr algn="ctr">
-              <a:spcBef>
-                <a:spcPts val="400"/>
-              </a:spcBef>
-              <a:defRPr sz="1000">
-                <a:solidFill>
-                  <a:srgbClr val="FFFFFF"/>
-                </a:solidFill>
-                <a:latin typeface="Arial" panose="020B0604020202020204"/>
-              </a:defRPr>
-            </a:pPr>
-            <a:r>
-              <a:t>3 Hạn chế lớn</a:t>
             </a:r>
           </a:p>
         </p:txBody>
@@ -19572,7 +19543,7 @@
         <p:spPr>
           <a:xfrm>
             <a:off x="2980944" y="1993392"/>
-            <a:ext cx="2682240" cy="1152144"/>
+            <a:ext cx="2682240" cy="763270"/>
           </a:xfrm>
           <a:prstGeom prst="rect">
             <a:avLst/>
@@ -19610,8 +19581,10 @@
               </a:defRPr>
             </a:pPr>
             <a:r>
-              <a:t>Các bài báo trước thường so sánh mô hình lượng tử với CNN tùy tiện, chênh lệch hàng nghìn tham số (không rõ ai mạnh hơn do đâu).</a:t>
-            </a:r>
+              <a:rPr sz="1050"/>
+              <a:t>Các bài báo trước thường so sánh mô hình lượng tử với CNN tùy tiện, chênh lệch hàng nghìn tham số .</a:t>
+            </a:r>
+            <a:endParaRPr sz="1050"/>
           </a:p>
         </p:txBody>
       </p:sp>
@@ -19624,7 +19597,7 @@
         <p:spPr>
           <a:xfrm>
             <a:off x="5754624" y="1993392"/>
-            <a:ext cx="2682240" cy="1152144"/>
+            <a:ext cx="2682240" cy="763270"/>
           </a:xfrm>
           <a:prstGeom prst="rect">
             <a:avLst/>
@@ -19662,8 +19635,10 @@
               </a:defRPr>
             </a:pPr>
             <a:r>
+              <a:rPr sz="1050"/>
               <a:t>Nhiều nghiên cứu chỉ chạy thử 1–2 lần ngẫu nhiên rồi vội kết luận 'lượng tử vượt trội', dễ do yếu tố may mắn.</a:t>
             </a:r>
+            <a:endParaRPr sz="1050"/>
           </a:p>
         </p:txBody>
       </p:sp>
@@ -19676,7 +19651,7 @@
         <p:spPr>
           <a:xfrm>
             <a:off x="8528304" y="1993392"/>
-            <a:ext cx="2682240" cy="1152144"/>
+            <a:ext cx="2682240" cy="763270"/>
           </a:xfrm>
           <a:prstGeom prst="rect">
             <a:avLst/>
@@ -19714,8 +19689,10 @@
               </a:defRPr>
             </a:pPr>
             <a:r>
+              <a:rPr sz="1050"/>
               <a:t>Chưa rõ việc cho các cổng lượng tử tự học (tối ưu góc) có thực sự đáng tiền so với việc cố định góc quay ngẫu nhiên.</a:t>
             </a:r>
+            <a:endParaRPr sz="1050"/>
           </a:p>
         </p:txBody>
       </p:sp>
@@ -19770,8 +19747,8 @@
         </p:nvSpPr>
         <p:spPr>
           <a:xfrm>
-            <a:off x="768096" y="3602736"/>
-            <a:ext cx="1865376" cy="786384"/>
+            <a:off x="768096" y="3718306"/>
+            <a:ext cx="1865376" cy="299085"/>
           </a:xfrm>
           <a:prstGeom prst="rect">
             <a:avLst/>
@@ -19794,22 +19771,6 @@
             </a:pPr>
             <a:r>
               <a:t>CÁCH XỬ LÝ</a:t>
-            </a:r>
-          </a:p>
-          <a:p>
-            <a:pPr algn="ctr">
-              <a:spcBef>
-                <a:spcPts val="400"/>
-              </a:spcBef>
-              <a:defRPr sz="1000">
-                <a:solidFill>
-                  <a:srgbClr val="E6F0FF"/>
-                </a:solidFill>
-                <a:latin typeface="Arial" panose="020B0604020202020204"/>
-              </a:defRPr>
-            </a:pPr>
-            <a:r>
-              <a:t>3 Giải pháp cốt lõi</a:t>
             </a:r>
           </a:p>
         </p:txBody>
@@ -19868,7 +19829,7 @@
         <p:spPr>
           <a:xfrm>
             <a:off x="2980944" y="3419856"/>
-            <a:ext cx="2682240" cy="1152144"/>
+            <a:ext cx="2682240" cy="763270"/>
           </a:xfrm>
           <a:prstGeom prst="rect">
             <a:avLst/>
@@ -19906,8 +19867,10 @@
               </a:defRPr>
             </a:pPr>
             <a:r>
+              <a:rPr sz="1050"/>
               <a:t>Giữ nguyên 100% phần phân loại, chỉ khác đúng bộ trích xuất đặc trưng (chênh đúng 20 tham số chuẩn đối sánh).</a:t>
             </a:r>
+            <a:endParaRPr sz="1050"/>
           </a:p>
         </p:txBody>
       </p:sp>
@@ -19919,8 +19882,8 @@
         </p:nvSpPr>
         <p:spPr>
           <a:xfrm>
-            <a:off x="5754624" y="3419856"/>
-            <a:ext cx="2682240" cy="1152144"/>
+            <a:off x="5754370" y="3420110"/>
+            <a:ext cx="2773680" cy="763270"/>
           </a:xfrm>
           <a:prstGeom prst="rect">
             <a:avLst/>
@@ -19958,8 +19921,10 @@
               </a:defRPr>
             </a:pPr>
             <a:r>
+              <a:rPr sz="1050"/>
               <a:t>Chạy lặp độc lập 10 lần cố định trên từng tập dữ liệu, tính độ lệch chuẩn và kiểm định thống kê y khoa (Paired t-test, Wilcoxon).</a:t>
             </a:r>
+            <a:endParaRPr sz="1050"/>
           </a:p>
         </p:txBody>
       </p:sp>
@@ -19971,8 +19936,8 @@
         </p:nvSpPr>
         <p:spPr>
           <a:xfrm>
-            <a:off x="8528304" y="3419856"/>
-            <a:ext cx="2682240" cy="1152144"/>
+            <a:off x="8528050" y="3420110"/>
+            <a:ext cx="2951480" cy="763270"/>
           </a:xfrm>
           <a:prstGeom prst="rect">
             <a:avLst/>
@@ -20010,8 +19975,10 @@
               </a:defRPr>
             </a:pPr>
             <a:r>
+              <a:rPr sz="1050"/>
               <a:t>So sánh trực tiếp 3 mô hình: CNN Cổ Điển vs Lượng Tử Cố Định (Frozen) vs Lượng Tử Tự Học (Trainable), đo chính xác thời gian.</a:t>
             </a:r>
+            <a:endParaRPr sz="1050"/>
           </a:p>
         </p:txBody>
       </p:sp>
@@ -20066,8 +20033,8 @@
         </p:nvSpPr>
         <p:spPr>
           <a:xfrm>
-            <a:off x="768096" y="5029200"/>
-            <a:ext cx="1865376" cy="786384"/>
+            <a:off x="768350" y="5144770"/>
+            <a:ext cx="1865630" cy="298450"/>
           </a:xfrm>
           <a:prstGeom prst="rect">
             <a:avLst/>
@@ -20076,7 +20043,7 @@
         </p:spPr>
         <p:txBody>
           <a:bodyPr wrap="square">
-            <a:spAutoFit/>
+            <a:noAutofit/>
           </a:bodyPr>
           <a:lstStyle/>
           <a:p>
@@ -20104,9 +20071,6 @@
                 <a:latin typeface="Arial" panose="020B0604020202020204"/>
               </a:defRPr>
             </a:pPr>
-            <a:r>
-              <a:t>3 Giá trị mang lại</a:t>
-            </a:r>
           </a:p>
         </p:txBody>
       </p:sp>
@@ -20163,8 +20127,8 @@
         </p:nvSpPr>
         <p:spPr>
           <a:xfrm>
-            <a:off x="2980944" y="4846320"/>
-            <a:ext cx="2682240" cy="1152144"/>
+            <a:off x="2980690" y="4846320"/>
+            <a:ext cx="2773680" cy="763270"/>
           </a:xfrm>
           <a:prstGeom prst="rect">
             <a:avLst/>
@@ -20202,8 +20166,26 @@
               </a:defRPr>
             </a:pPr>
             <a:r>
-              <a:t>Đo lường chính xác xem mạch lượng tử có thực sự trích xuất ảnh tốt hơn: ROC-AUC đạt 0.8521 trên dữ liệu nhỏ BreastMNIST.</a:t>
-            </a:r>
+              <a:rPr sz="1050"/>
+              <a:t>Đo lường chính xác xem mạch lượng tử có thực sự trích xuất ảnh tốt hơn</a:t>
+            </a:r>
+            <a:r>
+              <a:rPr lang="en-US" sz="1050"/>
+              <a:t> (</a:t>
+            </a:r>
+            <a:r>
+              <a:rPr sz="1050"/>
+              <a:t>ROC-AUC đạt 0.8521 trên dữ liệu nhỏ BreastMNIST</a:t>
+            </a:r>
+            <a:r>
+              <a:rPr lang="en-US" sz="1050"/>
+              <a:t>)</a:t>
+            </a:r>
+            <a:r>
+              <a:rPr sz="1050"/>
+              <a:t>.</a:t>
+            </a:r>
+            <a:endParaRPr sz="1050"/>
           </a:p>
         </p:txBody>
       </p:sp>
@@ -20216,7 +20198,7 @@
         <p:spPr>
           <a:xfrm>
             <a:off x="5754624" y="4846320"/>
-            <a:ext cx="2682240" cy="1152144"/>
+            <a:ext cx="2682240" cy="763270"/>
           </a:xfrm>
           <a:prstGeom prst="rect">
             <a:avLst/>
@@ -20254,8 +20236,10 @@
               </a:defRPr>
             </a:pPr>
             <a:r>
+              <a:rPr sz="1050"/>
               <a:t>Kết luận đưa ra là vững chắc, có ý nghĩa thống kê y khoa (p &lt; 0.05), loại trừ khả năng kết luận chỉ dựa trên may rủi.</a:t>
             </a:r>
+            <a:endParaRPr sz="1050"/>
           </a:p>
         </p:txBody>
       </p:sp>
@@ -20268,7 +20252,7 @@
         <p:spPr>
           <a:xfrm>
             <a:off x="8528304" y="4846320"/>
-            <a:ext cx="2682240" cy="1152144"/>
+            <a:ext cx="2682240" cy="763270"/>
           </a:xfrm>
           <a:prstGeom prst="rect">
             <a:avLst/>
@@ -20306,8 +20290,10 @@
               </a:defRPr>
             </a:pPr>
             <a:r>
+              <a:rPr sz="1050"/>
               <a:t>Chỉ rõ khi nào nên dùng mạch tĩnh ngẫu nhiên (tiết kiệm thời gian, 0 cần train) và khi nào cần mạch lượng tử tự học.</a:t>
             </a:r>
+            <a:endParaRPr sz="1050"/>
           </a:p>
         </p:txBody>
       </p:sp>
@@ -20742,10 +20728,16 @@
                 <a:solidFill>
                   <a:srgbClr val="1F4E79"/>
                 </a:solidFill>
-                <a:latin typeface="Arial"/>
+                <a:latin typeface="Arial" panose="020B0604020202020204"/>
               </a:rPr>
               <a:t>Tham số/tầng: Basic 4L · Strongly 12L · Random 0 (đóng băng)</a:t>
             </a:r>
+            <a:endParaRPr sz="1300" b="1">
+              <a:solidFill>
+                <a:srgbClr val="1F4E79"/>
+              </a:solidFill>
+              <a:latin typeface="Arial" panose="020B0604020202020204"/>
+            </a:endParaRPr>
           </a:p>
         </p:txBody>
       </p:sp>
@@ -20855,22 +20847,22 @@
       </p:sp>
       <p:pic>
         <p:nvPicPr>
-          <p:cNvPr id="6" name="Picture 5" descr="image.png"/>
+          <p:cNvPr id="6" name="Picture 5" descr="Fig1_pipeline_slide_simplified.png"/>
           <p:cNvPicPr>
             <a:picLocks noChangeAspect="1"/>
           </p:cNvPicPr>
           <p:nvPr/>
         </p:nvPicPr>
         <p:blipFill>
-          <a:blip r:embed="rId1"/>
+          <a:blip r:embed="rId4"/>
           <a:stretch>
             <a:fillRect/>
           </a:stretch>
         </p:blipFill>
         <p:spPr>
           <a:xfrm>
-            <a:off x="1672590" y="1724025"/>
-            <a:ext cx="9237345" cy="1913255"/>
+            <a:off x="1298448" y="1691640"/>
+            <a:ext cx="9601200" cy="1344168"/>
           </a:xfrm>
           <a:prstGeom prst="rect">
             <a:avLst/>
@@ -20879,7 +20871,7 @@
       </p:pic>
       <p:pic>
         <p:nvPicPr>
-          <p:cNvPr id="7" name="Picture 6" descr="Fig_quantum_circuit_architecture.png"/>
+          <p:cNvPr id="7" name="Picture 6" descr="image.png"/>
           <p:cNvPicPr>
             <a:picLocks noChangeAspect="1"/>
           </p:cNvPicPr>
@@ -20893,8 +20885,8 @@
         </p:blipFill>
         <p:spPr>
           <a:xfrm>
-            <a:off x="2286000" y="3768090"/>
-            <a:ext cx="8009890" cy="2588260"/>
+            <a:off x="2212848" y="3154680"/>
+            <a:ext cx="7772400" cy="3136392"/>
           </a:xfrm>
           <a:prstGeom prst="rect">
             <a:avLst/>
@@ -21091,7 +21083,11 @@
             </a:r>
             <a:r>
               <a:rPr sz="3500"/>
-              <a:t> BreastMNIST: </a:t>
+              <a:t> BreastMNIST</a:t>
+            </a:r>
+            <a:r>
+              <a:rPr lang="en-US" sz="3500"/>
+              <a:t>*</a:t>
             </a:r>
             <a:endParaRPr sz="3500"/>
           </a:p>
@@ -22200,7 +22196,7 @@
         <p:spPr>
           <a:xfrm>
             <a:off x="713232" y="6144768"/>
-            <a:ext cx="3566160" cy="256032"/>
+            <a:ext cx="4307840" cy="252730"/>
           </a:xfrm>
           <a:prstGeom prst="rect">
             <a:avLst/>
@@ -22213,15 +22209,28 @@
           </a:bodyPr>
           <a:lstStyle/>
           <a:p>
+            <a:pPr algn="l"/>
+            <a:r>
+              <a:rPr lang="en-US" sz="1050">
+                <a:sym typeface="+mn-ea"/>
+              </a:rPr>
+              <a:t>*: </a:t>
+            </a:r>
             <a:r>
               <a:rPr sz="1050">
                 <a:solidFill>
                   <a:srgbClr val="6B6B6B"/>
                 </a:solidFill>
-                <a:latin typeface="Arial"/>
+                <a:latin typeface="Arial" panose="020B0604020202020204"/>
               </a:rPr>
               <a:t>Số liệu: 10 seeds · mean ± std (ddof=1) · Nguồn: Bảng 4.1 luận văn</a:t>
             </a:r>
+            <a:endParaRPr sz="1050">
+              <a:solidFill>
+                <a:srgbClr val="6B6B6B"/>
+              </a:solidFill>
+              <a:latin typeface="Arial" panose="020B0604020202020204"/>
+            </a:endParaRPr>
           </a:p>
         </p:txBody>
       </p:sp>

</xml_diff>

<commit_message>
fix(slides): source notes on S9/S10 + param chips on S6 + sync with canonical numbers
</commit_message>
<xml_diff>
--- a/slides/KLTN_BaoCao_KhoaKTMT_ChinhThuc.pptx
+++ b/slides/KLTN_BaoCao_KhoaKTMT_ChinhThuc.pptx
@@ -20854,14 +20854,14 @@
           <p:nvPr/>
         </p:nvPicPr>
         <p:blipFill>
-          <a:blip r:embed="rId4"/>
+          <a:blip r:embed="rId1"/>
           <a:stretch>
             <a:fillRect/>
           </a:stretch>
         </p:blipFill>
         <p:spPr>
           <a:xfrm>
-            <a:off x="1298448" y="1691640"/>
+            <a:off x="1490218" y="1852295"/>
             <a:ext cx="9601200" cy="1344168"/>
           </a:xfrm>
           <a:prstGeom prst="rect">
@@ -20885,8 +20885,8 @@
         </p:blipFill>
         <p:spPr>
           <a:xfrm>
-            <a:off x="2212848" y="3154680"/>
-            <a:ext cx="7772400" cy="3136392"/>
+            <a:off x="2546985" y="3196590"/>
+            <a:ext cx="7204710" cy="3159760"/>
           </a:xfrm>
           <a:prstGeom prst="rect">
             <a:avLst/>

</xml_diff>